<commit_message>
python lambda program, function program 1-11 and provided data
</commit_message>
<xml_diff>
--- a/Sem-2/Python/Python Provided/PPTs/Functions-2.pptx
+++ b/Sem-2/Python/Python Provided/PPTs/Functions-2.pptx
@@ -27,6 +27,7 @@
     <p:sldId id="275" r:id="rId21"/>
     <p:sldId id="276" r:id="rId22"/>
     <p:sldId id="277" r:id="rId23"/>
+    <p:sldId id="278" r:id="rId24"/>
   </p:sldIdLst>
   <p:sldSz cx="9144000" cy="6858000" type="screen4x3"/>
   <p:notesSz cx="6858000" cy="9144000"/>
@@ -326,7 +327,7 @@
             <a:fld id="{1D8BD707-D9CF-40AE-B4C6-C98DA3205C09}" type="datetimeFigureOut">
               <a:rPr lang="en-US" smtClean="0"/>
               <a:pPr/>
-              <a:t>12/21/2020</a:t>
+              <a:t>2/14/2026</a:t>
             </a:fld>
             <a:endParaRPr lang="en-US"/>
           </a:p>
@@ -493,7 +494,7 @@
             <a:fld id="{1D8BD707-D9CF-40AE-B4C6-C98DA3205C09}" type="datetimeFigureOut">
               <a:rPr lang="en-US" smtClean="0"/>
               <a:pPr/>
-              <a:t>12/21/2020</a:t>
+              <a:t>2/14/2026</a:t>
             </a:fld>
             <a:endParaRPr lang="en-US"/>
           </a:p>
@@ -670,7 +671,7 @@
             <a:fld id="{1D8BD707-D9CF-40AE-B4C6-C98DA3205C09}" type="datetimeFigureOut">
               <a:rPr lang="en-US" smtClean="0"/>
               <a:pPr/>
-              <a:t>12/21/2020</a:t>
+              <a:t>2/14/2026</a:t>
             </a:fld>
             <a:endParaRPr lang="en-US"/>
           </a:p>
@@ -837,7 +838,7 @@
             <a:fld id="{1D8BD707-D9CF-40AE-B4C6-C98DA3205C09}" type="datetimeFigureOut">
               <a:rPr lang="en-US" smtClean="0"/>
               <a:pPr/>
-              <a:t>12/21/2020</a:t>
+              <a:t>2/14/2026</a:t>
             </a:fld>
             <a:endParaRPr lang="en-US"/>
           </a:p>
@@ -1080,7 +1081,7 @@
             <a:fld id="{1D8BD707-D9CF-40AE-B4C6-C98DA3205C09}" type="datetimeFigureOut">
               <a:rPr lang="en-US" smtClean="0"/>
               <a:pPr/>
-              <a:t>12/21/2020</a:t>
+              <a:t>2/14/2026</a:t>
             </a:fld>
             <a:endParaRPr lang="en-US"/>
           </a:p>
@@ -1365,7 +1366,7 @@
             <a:fld id="{1D8BD707-D9CF-40AE-B4C6-C98DA3205C09}" type="datetimeFigureOut">
               <a:rPr lang="en-US" smtClean="0"/>
               <a:pPr/>
-              <a:t>12/21/2020</a:t>
+              <a:t>2/14/2026</a:t>
             </a:fld>
             <a:endParaRPr lang="en-US"/>
           </a:p>
@@ -1784,7 +1785,7 @@
             <a:fld id="{1D8BD707-D9CF-40AE-B4C6-C98DA3205C09}" type="datetimeFigureOut">
               <a:rPr lang="en-US" smtClean="0"/>
               <a:pPr/>
-              <a:t>12/21/2020</a:t>
+              <a:t>2/14/2026</a:t>
             </a:fld>
             <a:endParaRPr lang="en-US"/>
           </a:p>
@@ -1899,7 +1900,7 @@
             <a:fld id="{1D8BD707-D9CF-40AE-B4C6-C98DA3205C09}" type="datetimeFigureOut">
               <a:rPr lang="en-US" smtClean="0"/>
               <a:pPr/>
-              <a:t>12/21/2020</a:t>
+              <a:t>2/14/2026</a:t>
             </a:fld>
             <a:endParaRPr lang="en-US"/>
           </a:p>
@@ -1991,7 +1992,7 @@
             <a:fld id="{1D8BD707-D9CF-40AE-B4C6-C98DA3205C09}" type="datetimeFigureOut">
               <a:rPr lang="en-US" smtClean="0"/>
               <a:pPr/>
-              <a:t>12/21/2020</a:t>
+              <a:t>2/14/2026</a:t>
             </a:fld>
             <a:endParaRPr lang="en-US"/>
           </a:p>
@@ -2265,7 +2266,7 @@
             <a:fld id="{1D8BD707-D9CF-40AE-B4C6-C98DA3205C09}" type="datetimeFigureOut">
               <a:rPr lang="en-US" smtClean="0"/>
               <a:pPr/>
-              <a:t>12/21/2020</a:t>
+              <a:t>2/14/2026</a:t>
             </a:fld>
             <a:endParaRPr lang="en-US"/>
           </a:p>
@@ -2515,7 +2516,7 @@
             <a:fld id="{1D8BD707-D9CF-40AE-B4C6-C98DA3205C09}" type="datetimeFigureOut">
               <a:rPr lang="en-US" smtClean="0"/>
               <a:pPr/>
-              <a:t>12/21/2020</a:t>
+              <a:t>2/14/2026</a:t>
             </a:fld>
             <a:endParaRPr lang="en-US"/>
           </a:p>
@@ -2725,7 +2726,7 @@
             <a:fld id="{1D8BD707-D9CF-40AE-B4C6-C98DA3205C09}" type="datetimeFigureOut">
               <a:rPr lang="en-US" smtClean="0"/>
               <a:pPr/>
-              <a:t>12/21/2020</a:t>
+              <a:t>2/14/2026</a:t>
             </a:fld>
             <a:endParaRPr lang="en-US"/>
           </a:p>
@@ -6009,6 +6010,134 @@
 </p:sld>
 </file>
 
+<file path=ppt/slides/slide23.xml><?xml version="1.0" encoding="utf-8"?>
+<p:sld xmlns:a="http://schemas.openxmlformats.org/drawingml/2006/main" xmlns:r="http://schemas.openxmlformats.org/officeDocument/2006/relationships" xmlns:p="http://schemas.openxmlformats.org/presentationml/2006/main">
+  <p:cSld>
+    <p:spTree>
+      <p:nvGrpSpPr>
+        <p:cNvPr id="1" name=""/>
+        <p:cNvGrpSpPr/>
+        <p:nvPr/>
+      </p:nvGrpSpPr>
+      <p:grpSpPr>
+        <a:xfrm>
+          <a:off x="0" y="0"/>
+          <a:ext cx="0" cy="0"/>
+          <a:chOff x="0" y="0"/>
+          <a:chExt cx="0" cy="0"/>
+        </a:xfrm>
+      </p:grpSpPr>
+      <p:sp>
+        <p:nvSpPr>
+          <p:cNvPr id="2" name="Title 1"/>
+          <p:cNvSpPr>
+            <a:spLocks noGrp="1"/>
+          </p:cNvSpPr>
+          <p:nvPr>
+            <p:ph type="title"/>
+          </p:nvPr>
+        </p:nvSpPr>
+        <p:spPr/>
+        <p:txBody>
+          <a:bodyPr/>
+          <a:lstStyle/>
+          <a:p>
+            <a:r>
+              <a:rPr lang="en-US" dirty="0" smtClean="0"/>
+              <a:t>Filter()</a:t>
+            </a:r>
+            <a:endParaRPr lang="en-US" dirty="0"/>
+          </a:p>
+        </p:txBody>
+      </p:sp>
+      <p:sp>
+        <p:nvSpPr>
+          <p:cNvPr id="3" name="Content Placeholder 2"/>
+          <p:cNvSpPr>
+            <a:spLocks noGrp="1"/>
+          </p:cNvSpPr>
+          <p:nvPr>
+            <p:ph idx="1"/>
+          </p:nvPr>
+        </p:nvSpPr>
+        <p:spPr/>
+        <p:txBody>
+          <a:bodyPr/>
+          <a:lstStyle/>
+          <a:p>
+            <a:r>
+              <a:rPr lang="en-US" dirty="0" smtClean="0"/>
+              <a:t>This function is used to filter out the elements of a sequence depending on the result of the function.</a:t>
+            </a:r>
+          </a:p>
+          <a:p>
+            <a:pPr marL="0" indent="0">
+              <a:buNone/>
+            </a:pPr>
+            <a:r>
+              <a:rPr lang="en-US" dirty="0"/>
+              <a:t> </a:t>
+            </a:r>
+            <a:r>
+              <a:rPr lang="en-US" dirty="0" smtClean="0"/>
+              <a:t>       filter(</a:t>
+            </a:r>
+            <a:r>
+              <a:rPr lang="en-US" dirty="0" err="1" smtClean="0"/>
+              <a:t>function,sequence</a:t>
+            </a:r>
+            <a:r>
+              <a:rPr lang="en-US" dirty="0" smtClean="0"/>
+              <a:t>)</a:t>
+            </a:r>
+          </a:p>
+          <a:p>
+            <a:pPr marL="0" indent="0">
+              <a:buNone/>
+            </a:pPr>
+            <a:r>
+              <a:rPr lang="en-US" dirty="0" smtClean="0"/>
+              <a:t>Function – function name that returns true or false</a:t>
+            </a:r>
+          </a:p>
+          <a:p>
+            <a:pPr marL="0" indent="0">
+              <a:buNone/>
+            </a:pPr>
+            <a:r>
+              <a:rPr lang="en-US" dirty="0" smtClean="0"/>
+              <a:t>Sequence- represents </a:t>
+            </a:r>
+            <a:r>
+              <a:rPr lang="en-US" dirty="0" err="1" smtClean="0"/>
+              <a:t>list,string</a:t>
+            </a:r>
+            <a:r>
+              <a:rPr lang="en-US" dirty="0" smtClean="0"/>
+              <a:t> or tuple</a:t>
+            </a:r>
+          </a:p>
+          <a:p>
+            <a:pPr marL="0" indent="0">
+              <a:buNone/>
+            </a:pPr>
+            <a:endParaRPr lang="en-US" dirty="0"/>
+          </a:p>
+        </p:txBody>
+      </p:sp>
+    </p:spTree>
+    <p:extLst>
+      <p:ext uri="{BB962C8B-B14F-4D97-AF65-F5344CB8AC3E}">
+        <p14:creationId xmlns:p14="http://schemas.microsoft.com/office/powerpoint/2010/main" val="266093674"/>
+      </p:ext>
+    </p:extLst>
+  </p:cSld>
+  <p:clrMapOvr>
+    <a:masterClrMapping/>
+  </p:clrMapOvr>
+</p:sld>
+</file>
+
 <file path=ppt/slides/slide3.xml><?xml version="1.0" encoding="utf-8"?>
 <p:sld xmlns:a="http://schemas.openxmlformats.org/drawingml/2006/main" xmlns:r="http://schemas.openxmlformats.org/officeDocument/2006/relationships" xmlns:p="http://schemas.openxmlformats.org/presentationml/2006/main">
   <p:cSld>
@@ -6309,11 +6438,7 @@
             </a:r>
             <a:r>
               <a:rPr lang="en-US" sz="2800" smtClean="0"/>
-              <a:t> </a:t>
-            </a:r>
-            <a:r>
-              <a:rPr lang="en-US" sz="2800" smtClean="0"/>
-              <a:t>contains </a:t>
+              <a:t> contains </a:t>
             </a:r>
             <a:r>
               <a:rPr lang="en-US" sz="2800" dirty="0" smtClean="0"/>

</xml_diff>